<commit_message>
Add defense prep materials and demo assets
</commit_message>
<xml_diff>
--- a/outputs/PESU_MTech_Phase1_ZVF_Defense_ArvindCR.pptx
+++ b/outputs/PESU_MTech_Phase1_ZVF_Defense_ArvindCR.pptx
@@ -2527,6 +2527,66 @@
           </a:p>
         </p:txBody>
       </p:sp>
+      <p:pic xmlns:a="http://schemas.openxmlformats.org/drawingml/2006/main" xmlns:r="http://schemas.openxmlformats.org/officeDocument/2006/relationships">
+        <p:nvPicPr>
+          <p:cNvPr id="12" name="Picture 11" descr="title_cookoff.jpg"/>
+          <p:cNvPicPr>
+            <a:picLocks noChangeAspect="1"/>
+          </p:cNvPicPr>
+          <p:nvPr/>
+        </p:nvPicPr>
+        <p:blipFill>
+          <a:blip r:embed="rId3"/>
+          <a:stretch>
+            <a:fillRect/>
+          </a:stretch>
+        </p:blipFill>
+        <p:spPr>
+          <a:xfrm>
+            <a:off x="475488" y="5047488"/>
+            <a:ext cx="3694176" cy="1298448"/>
+          </a:xfrm>
+          <a:prstGeom prst="rect">
+            <a:avLst/>
+          </a:prstGeom>
+          <a:ln w="15875">
+            <a:solidFill>
+              <a:srgbClr val="2DD4BF"/>
+            </a:solidFill>
+          </a:ln>
+          <a:effectLst/>
+        </p:spPr>
+      </p:pic>
+      <p:pic xmlns:a="http://schemas.openxmlformats.org/drawingml/2006/main" xmlns:r="http://schemas.openxmlformats.org/officeDocument/2006/relationships">
+        <p:nvPicPr>
+          <p:cNvPr id="13" name="Picture 12" descr="title_jumpshot.jpg"/>
+          <p:cNvPicPr>
+            <a:picLocks noChangeAspect="1"/>
+          </p:cNvPicPr>
+          <p:nvPr/>
+        </p:nvPicPr>
+        <p:blipFill>
+          <a:blip r:embed="rId4"/>
+          <a:stretch>
+            <a:fillRect/>
+          </a:stretch>
+        </p:blipFill>
+        <p:spPr>
+          <a:xfrm>
+            <a:off x="4389120" y="5047488"/>
+            <a:ext cx="3694176" cy="1298448"/>
+          </a:xfrm>
+          <a:prstGeom prst="rect">
+            <a:avLst/>
+          </a:prstGeom>
+          <a:ln w="15875">
+            <a:solidFill>
+              <a:srgbClr val="2DD4BF"/>
+            </a:solidFill>
+          </a:ln>
+          <a:effectLst/>
+        </p:spPr>
+      </p:pic>
     </p:spTree>
     <p:extLst>
       <p:ext uri="{BB962C8B-B14F-4D97-AF65-F5344CB8AC3E}">

</xml_diff>